<commit_message>
docs: add tooling-install slide to Lab 1.b deck (macOS + Windows)
Co-Authored-By: Claude Fable 5 <noreply@anthropic.com>
</commit_message>
<xml_diff>
--- a/docs/instructor/lab-1b-bugfix-test-driven.pptx
+++ b/docs/instructor/lab-1b-bugfix-test-driven.pptx
@@ -7,6 +7,7 @@
   <p:sldIdLst>
     <p:sldId id="256" r:id="rId7"/>
     <p:sldId id="257" r:id="rId8"/>
+    <p:sldId id="280" r:id="rId32"/>
     <p:sldId id="258" r:id="rId9"/>
     <p:sldId id="259" r:id="rId10"/>
     <p:sldId id="260" r:id="rId11"/>
@@ -1670,6 +1671,76 @@
 </p:notes>
 </file>
 
+<file path=ppt/notesSlides/notesSlide25.xml><?xml version="1.0" encoding="utf-8"?>
+<p:notes xmlns:a="http://schemas.openxmlformats.org/drawingml/2006/main" xmlns:p="http://schemas.openxmlformats.org/presentationml/2006/main" xmlns:r="http://schemas.openxmlformats.org/officeDocument/2006/relationships">
+  <p:cSld>
+    <p:spTree>
+      <p:nvGrpSpPr>
+        <p:cNvPr id="1" name=""/>
+        <p:cNvGrpSpPr/>
+        <p:nvPr/>
+      </p:nvGrpSpPr>
+      <p:grpSpPr>
+        <a:xfrm>
+          <a:off x="0" y="0"/>
+          <a:ext cx="0" cy="0"/>
+          <a:chOff x="0" y="0"/>
+          <a:chExt cx="0" cy="0"/>
+        </a:xfrm>
+      </p:grpSpPr>
+      <p:sp>
+        <p:nvSpPr>
+          <p:cNvPr id="2" name="Slide Image Placeholder 1"/>
+          <p:cNvSpPr>
+            <a:spLocks noGrp="1"/>
+          </p:cNvSpPr>
+          <p:nvPr>
+            <p:ph type="sldImg" idx="2"/>
+          </p:nvPr>
+        </p:nvSpPr>
+        <p:spPr/>
+      </p:sp>
+      <p:sp>
+        <p:nvSpPr>
+          <p:cNvPr id="3" name="Notes Placeholder 2"/>
+          <p:cNvSpPr>
+            <a:spLocks noGrp="1"/>
+          </p:cNvSpPr>
+          <p:nvPr>
+            <p:ph type="body" idx="3" sz="quarter"/>
+          </p:nvPr>
+        </p:nvSpPr>
+        <p:spPr/>
+        <p:txBody>
+          <a:bodyPr/>
+          <a:lstStyle/>
+          <a:p>
+            <a:r>
+              <a:t>One-time install, ideally before lab day (~10 min). macOS column assumes Homebrew, Windows assumes winget (built into Win 10/11) — fallback for both is each tool’s download page. Why each tool: git drives the branch/PR flow; nvm makes `nvm use` match the repo’s .nvmrc; Node floor is LTS 20.19+ because Vite 7 requires it — 20, 22, or 24 LTS all work, odd majors (23) print engine warnings that confuse people; GitHub CLI powers the issue-seeding script and PR flow (`gh auth login` is the step people forget); Claude Code uses the native installer — self-updating and avoids npm -g permission problems on locked-down machines; any editor is fine, the demo narrates from VS Code. Accounts: a GitHub account plus an EDS-provisioned Claude Code seat — have everyone run the VERIFY line and complete a Claude login BEFORE lab day; pair anyone broken at the door rather than during the demo.</a:t>
+            </a:r>
+          </a:p>
+        </p:txBody>
+      </p:sp>
+      <p:sp>
+        <p:nvSpPr>
+          <p:cNvPr id="4" name="Slide Number Placeholder 3"/>
+          <p:cNvSpPr>
+            <a:spLocks noGrp="1"/>
+          </p:cNvSpPr>
+          <p:nvPr>
+            <p:ph type="sldNum" idx="5" sz="quarter"/>
+          </p:nvPr>
+        </p:nvSpPr>
+        <p:spPr/>
+      </p:sp>
+    </p:spTree>
+  </p:cSld>
+  <p:clrMapOvr>
+    <a:masterClrMapping/>
+  </p:clrMapOvr>
+</p:notes>
+</file>
+
 <file path=ppt/notesSlides/notesSlide3.xml><?xml version="1.0" encoding="utf-8"?>
 <p:notes xmlns:a="http://schemas.openxmlformats.org/drawingml/2006/main" xmlns:p="http://schemas.openxmlformats.org/presentationml/2006/main" xmlns:r="http://schemas.openxmlformats.org/officeDocument/2006/relationships">
   <p:cSld>
@@ -1715,7 +1786,7 @@
           <a:lstStyle/>
           <a:p>
             <a:r>
-              <a:t>Do this before anything hands-on (~2 min). Repo: github.com/mike-tajmajer-fullstacklabs/fsl-taskboard-lab (shown top-left). The green 'Use this template → Create a new repository' button (circled in the screenshot) makes their OWN copy — not Fork, not plain Clone. Then the setup script (`./scripts/setup-repo.sh`, or `.ps1` on Windows) seeds the lab labels + backlog issues, since template copies don't inherit issues — they'll need `gh auth login` first. Then `npm install` / `npm run reset-db` / `npm run dev` (Node 20+). Confirm `npm test` is green, then pick a `lab-1` issue. If anyone's stuck here, pair them before the demo.</a:t>
+              <a:t>Do this before anything hands-on (~2 min). Repo: github.com/mike-tajmajer-fullstacklabs/fsl-taskboard-lab (shown top-left). The green 'Use this template → Create a new repository' button (circled in the screenshot) makes their OWN copy — not Fork, not plain Clone. Then the setup script (`./scripts/setup-repo.sh`, or `.ps1` on Windows) seeds the lab labels + backlog issues, since template copies don't inherit issues — gh auth was handled on the tooling slide. Then `npm install` / `npm run reset-db` / `npm run dev` (Node LTS ≥ 20.19; `nvm use` reads .nvmrc). Confirm `npm test` is green, then pick a `lab-1` issue. If anyone's stuck here, pair them before the demo. Tooling itself was installed on the previous slide — this slide is only about the repo.</a:t>
             </a:r>
           </a:p>
         </p:txBody>
@@ -16845,6 +16916,1478 @@
 </p:sld>
 </file>
 
+<file path=ppt/slides/slide25.xml><?xml version="1.0" encoding="utf-8"?>
+<p:sld xmlns:a="http://schemas.openxmlformats.org/drawingml/2006/main" xmlns:p="http://schemas.openxmlformats.org/presentationml/2006/main" xmlns:r="http://schemas.openxmlformats.org/officeDocument/2006/relationships">
+  <p:cSld>
+    <p:spTree>
+      <p:nvGrpSpPr>
+        <p:cNvPr id="1" name=""/>
+        <p:cNvGrpSpPr/>
+        <p:nvPr/>
+      </p:nvGrpSpPr>
+      <p:grpSpPr/>
+      <p:sp>
+        <p:nvSpPr>
+          <p:cNvPr id="2" name="Rectangle 1"/>
+          <p:cNvSpPr/>
+          <p:nvPr/>
+        </p:nvSpPr>
+        <p:spPr>
+          <a:xfrm>
+            <a:off x="0" y="0"/>
+            <a:ext cx="9144000" cy="5143500"/>
+          </a:xfrm>
+          <a:prstGeom prst="rect">
+            <a:avLst/>
+          </a:prstGeom>
+          <a:solidFill>
+            <a:srgbClr val="FFFFFF"/>
+          </a:solidFill>
+          <a:ln>
+            <a:noFill/>
+          </a:ln>
+          <a:effectLst/>
+        </p:spPr>
+        <p:style>
+          <a:lnRef idx="1">
+            <a:schemeClr val="accent1"/>
+          </a:lnRef>
+          <a:fillRef idx="3">
+            <a:schemeClr val="accent1"/>
+          </a:fillRef>
+          <a:effectRef idx="2">
+            <a:schemeClr val="accent1"/>
+          </a:effectRef>
+          <a:fontRef idx="minor">
+            <a:schemeClr val="lt1"/>
+          </a:fontRef>
+        </p:style>
+        <p:txBody>
+          <a:bodyPr rtlCol="0" anchor="ctr"/>
+          <a:lstStyle/>
+          <a:p>
+            <a:pPr algn="ctr"/>
+          </a:p>
+        </p:txBody>
+      </p:sp>
+      <p:pic>
+        <p:nvPicPr>
+          <p:cNvPr id="3" name="Picture 2" descr="image.png"/>
+          <p:cNvPicPr>
+            <a:picLocks noChangeAspect="1"/>
+          </p:cNvPicPr>
+          <p:nvPr/>
+        </p:nvPicPr>
+        <p:blipFill>
+          <a:blip r:embed="rId2"/>
+          <a:stretch>
+            <a:fillRect/>
+          </a:stretch>
+        </p:blipFill>
+        <p:spPr>
+          <a:xfrm>
+            <a:off x="8229600" y="411480"/>
+            <a:ext cx="713741" cy="384048"/>
+          </a:xfrm>
+          <a:prstGeom prst="rect">
+            <a:avLst/>
+          </a:prstGeom>
+        </p:spPr>
+      </p:pic>
+      <p:sp>
+        <p:nvSpPr>
+          <p:cNvPr id="4" name="Rectangle 3"/>
+          <p:cNvSpPr/>
+          <p:nvPr/>
+        </p:nvSpPr>
+        <p:spPr>
+          <a:xfrm>
+            <a:off x="548640" y="457200"/>
+            <a:ext cx="237744" cy="50292"/>
+          </a:xfrm>
+          <a:prstGeom prst="rect">
+            <a:avLst/>
+          </a:prstGeom>
+          <a:solidFill>
+            <a:srgbClr val="403FE8"/>
+          </a:solidFill>
+          <a:ln>
+            <a:noFill/>
+          </a:ln>
+          <a:effectLst/>
+        </p:spPr>
+        <p:style>
+          <a:lnRef idx="1">
+            <a:schemeClr val="accent1"/>
+          </a:lnRef>
+          <a:fillRef idx="3">
+            <a:schemeClr val="accent1"/>
+          </a:fillRef>
+          <a:effectRef idx="2">
+            <a:schemeClr val="accent1"/>
+          </a:effectRef>
+          <a:fontRef idx="minor">
+            <a:schemeClr val="lt1"/>
+          </a:fontRef>
+        </p:style>
+        <p:txBody>
+          <a:bodyPr rtlCol="0" anchor="ctr"/>
+          <a:lstStyle/>
+          <a:p>
+            <a:pPr algn="ctr"/>
+          </a:p>
+        </p:txBody>
+      </p:sp>
+      <p:sp>
+        <p:nvSpPr>
+          <p:cNvPr id="5" name="TextBox 4"/>
+          <p:cNvSpPr txBox="1"/>
+          <p:nvPr/>
+        </p:nvSpPr>
+        <p:spPr>
+          <a:xfrm>
+            <a:off x="868680" y="402336"/>
+            <a:ext cx="7132320" cy="274320"/>
+          </a:xfrm>
+          <a:prstGeom prst="rect">
+            <a:avLst/>
+          </a:prstGeom>
+          <a:noFill/>
+        </p:spPr>
+        <p:txBody>
+          <a:bodyPr wrap="square">
+            <a:spAutoFit/>
+          </a:bodyPr>
+          <a:lstStyle/>
+          <a:p>
+            <a:r>
+              <a:rPr sz="1150" b="1">
+                <a:solidFill>
+                  <a:srgbClr val="403FE8"/>
+                </a:solidFill>
+                <a:latin typeface="Arial"/>
+              </a:rPr>
+              <a:t>SETUP</a:t>
+            </a:r>
+          </a:p>
+        </p:txBody>
+      </p:sp>
+      <p:sp>
+        <p:nvSpPr>
+          <p:cNvPr id="6" name="TextBox 5"/>
+          <p:cNvSpPr txBox="1"/>
+          <p:nvPr/>
+        </p:nvSpPr>
+        <p:spPr>
+          <a:xfrm>
+            <a:off x="548640" y="676656"/>
+            <a:ext cx="7589520" cy="640080"/>
+          </a:xfrm>
+          <a:prstGeom prst="rect">
+            <a:avLst/>
+          </a:prstGeom>
+          <a:noFill/>
+        </p:spPr>
+        <p:txBody>
+          <a:bodyPr wrap="square">
+            <a:spAutoFit/>
+          </a:bodyPr>
+          <a:lstStyle/>
+          <a:p>
+            <a:r>
+              <a:rPr sz="2500" b="1">
+                <a:solidFill>
+                  <a:srgbClr val="13135E"/>
+                </a:solidFill>
+                <a:latin typeface="Arial"/>
+              </a:rPr>
+              <a:t>Install your tooling</a:t>
+            </a:r>
+          </a:p>
+        </p:txBody>
+      </p:sp>
+      <p:sp>
+        <p:nvSpPr>
+          <p:cNvPr id="7" name="TextBox 6"/>
+          <p:cNvSpPr txBox="1"/>
+          <p:nvPr/>
+        </p:nvSpPr>
+        <p:spPr>
+          <a:xfrm>
+            <a:off x="548640" y="1234440"/>
+            <a:ext cx="8046720" cy="274320"/>
+          </a:xfrm>
+          <a:prstGeom prst="rect">
+            <a:avLst/>
+          </a:prstGeom>
+          <a:noFill/>
+        </p:spPr>
+        <p:txBody>
+          <a:bodyPr wrap="square">
+            <a:spAutoFit/>
+          </a:bodyPr>
+          <a:lstStyle/>
+          <a:p>
+            <a:r>
+              <a:rPr sz="1100" b="0">
+                <a:solidFill>
+                  <a:srgbClr val="434343"/>
+                </a:solidFill>
+                <a:latin typeface="Arial"/>
+              </a:rPr>
+              <a:t>One-time, before lab day — macOS via Homebrew, Windows via winget.</a:t>
+            </a:r>
+          </a:p>
+        </p:txBody>
+      </p:sp>
+      <p:sp>
+        <p:nvSpPr>
+          <p:cNvPr id="8" name="TextBox 7"/>
+          <p:cNvSpPr txBox="1"/>
+          <p:nvPr/>
+        </p:nvSpPr>
+        <p:spPr>
+          <a:xfrm>
+            <a:off x="548640" y="4846320"/>
+            <a:ext cx="7315200" cy="219456"/>
+          </a:xfrm>
+          <a:prstGeom prst="rect">
+            <a:avLst/>
+          </a:prstGeom>
+          <a:noFill/>
+        </p:spPr>
+        <p:txBody>
+          <a:bodyPr wrap="square">
+            <a:spAutoFit/>
+          </a:bodyPr>
+          <a:lstStyle/>
+          <a:p>
+            <a:r>
+              <a:rPr sz="850" b="0">
+                <a:solidFill>
+                  <a:srgbClr val="999999"/>
+                </a:solidFill>
+                <a:latin typeface="Arial"/>
+              </a:rPr>
+              <a:t>FSL AI Training · Lab 1.b — Fixing Bugs, Test-First</a:t>
+            </a:r>
+          </a:p>
+        </p:txBody>
+      </p:sp>
+      <p:sp>
+        <p:nvSpPr>
+          <p:cNvPr id="9" name="Rounded Rectangle 8"/>
+          <p:cNvSpPr/>
+          <p:nvPr/>
+        </p:nvSpPr>
+        <p:spPr>
+          <a:xfrm>
+            <a:off x="548640" y="1554480"/>
+            <a:ext cx="8046720" cy="320040"/>
+          </a:xfrm>
+          <a:prstGeom prst="roundRect">
+            <a:avLst/>
+          </a:prstGeom>
+          <a:solidFill>
+            <a:srgbClr val="13135E"/>
+          </a:solidFill>
+          <a:ln>
+            <a:noFill/>
+          </a:ln>
+          <a:effectLst/>
+        </p:spPr>
+        <p:style>
+          <a:lnRef idx="1">
+            <a:schemeClr val="accent1"/>
+          </a:lnRef>
+          <a:fillRef idx="3">
+            <a:schemeClr val="accent1"/>
+          </a:fillRef>
+          <a:effectRef idx="2">
+            <a:schemeClr val="accent1"/>
+          </a:effectRef>
+          <a:fontRef idx="minor">
+            <a:schemeClr val="lt1"/>
+          </a:fontRef>
+        </p:style>
+        <p:txBody>
+          <a:bodyPr rtlCol="0" anchor="ctr"/>
+          <a:lstStyle/>
+          <a:p>
+            <a:pPr algn="ctr"/>
+          </a:p>
+        </p:txBody>
+      </p:sp>
+      <p:sp>
+        <p:nvSpPr>
+          <p:cNvPr id="10" name="TextBox 9"/>
+          <p:cNvSpPr txBox="1"/>
+          <p:nvPr/>
+        </p:nvSpPr>
+        <p:spPr>
+          <a:xfrm>
+            <a:off x="731520" y="1577340"/>
+            <a:ext cx="1554480" cy="274320"/>
+          </a:xfrm>
+          <a:prstGeom prst="rect">
+            <a:avLst/>
+          </a:prstGeom>
+          <a:noFill/>
+        </p:spPr>
+        <p:txBody>
+          <a:bodyPr wrap="square">
+            <a:spAutoFit/>
+          </a:bodyPr>
+          <a:lstStyle/>
+          <a:p>
+            <a:r>
+              <a:rPr sz="950" b="1">
+                <a:solidFill>
+                  <a:srgbClr val="FFFFFF"/>
+                </a:solidFill>
+                <a:latin typeface="Arial"/>
+              </a:rPr>
+              <a:t>Tool</a:t>
+            </a:r>
+          </a:p>
+        </p:txBody>
+      </p:sp>
+      <p:sp>
+        <p:nvSpPr>
+          <p:cNvPr id="11" name="TextBox 10"/>
+          <p:cNvSpPr txBox="1"/>
+          <p:nvPr/>
+        </p:nvSpPr>
+        <p:spPr>
+          <a:xfrm>
+            <a:off x="2377440" y="1577340"/>
+            <a:ext cx="3016000" cy="274320"/>
+          </a:xfrm>
+          <a:prstGeom prst="rect">
+            <a:avLst/>
+          </a:prstGeom>
+          <a:noFill/>
+        </p:spPr>
+        <p:txBody>
+          <a:bodyPr wrap="square">
+            <a:spAutoFit/>
+          </a:bodyPr>
+          <a:lstStyle/>
+          <a:p>
+            <a:r>
+              <a:rPr sz="950" b="1">
+                <a:solidFill>
+                  <a:srgbClr val="FFFFFF"/>
+                </a:solidFill>
+                <a:latin typeface="Arial"/>
+              </a:rPr>
+              <a:t>macOS</a:t>
+            </a:r>
+          </a:p>
+        </p:txBody>
+      </p:sp>
+      <p:sp>
+        <p:nvSpPr>
+          <p:cNvPr id="12" name="TextBox 11"/>
+          <p:cNvSpPr txBox="1"/>
+          <p:nvPr/>
+        </p:nvSpPr>
+        <p:spPr>
+          <a:xfrm>
+            <a:off x="5486400" y="1577340"/>
+            <a:ext cx="3016000" cy="274320"/>
+          </a:xfrm>
+          <a:prstGeom prst="rect">
+            <a:avLst/>
+          </a:prstGeom>
+          <a:noFill/>
+        </p:spPr>
+        <p:txBody>
+          <a:bodyPr wrap="square">
+            <a:spAutoFit/>
+          </a:bodyPr>
+          <a:lstStyle/>
+          <a:p>
+            <a:r>
+              <a:rPr sz="950" b="1">
+                <a:solidFill>
+                  <a:srgbClr val="FFFFFF"/>
+                </a:solidFill>
+                <a:latin typeface="Arial"/>
+              </a:rPr>
+              <a:t>Windows</a:t>
+            </a:r>
+          </a:p>
+        </p:txBody>
+      </p:sp>
+      <p:sp>
+        <p:nvSpPr>
+          <p:cNvPr id="13" name="Rounded Rectangle 12"/>
+          <p:cNvSpPr/>
+          <p:nvPr/>
+        </p:nvSpPr>
+        <p:spPr>
+          <a:xfrm>
+            <a:off x="548640" y="1920240"/>
+            <a:ext cx="8046720" cy="393192"/>
+          </a:xfrm>
+          <a:prstGeom prst="roundRect">
+            <a:avLst/>
+          </a:prstGeom>
+          <a:solidFill>
+            <a:srgbClr val="E2ECFF"/>
+          </a:solidFill>
+          <a:ln>
+            <a:noFill/>
+          </a:ln>
+          <a:effectLst/>
+        </p:spPr>
+        <p:style>
+          <a:lnRef idx="1">
+            <a:schemeClr val="accent1"/>
+          </a:lnRef>
+          <a:fillRef idx="3">
+            <a:schemeClr val="accent1"/>
+          </a:fillRef>
+          <a:effectRef idx="2">
+            <a:schemeClr val="accent1"/>
+          </a:effectRef>
+          <a:fontRef idx="minor">
+            <a:schemeClr val="lt1"/>
+          </a:fontRef>
+        </p:style>
+        <p:txBody>
+          <a:bodyPr rtlCol="0" anchor="ctr"/>
+          <a:lstStyle/>
+          <a:p>
+            <a:pPr algn="ctr"/>
+          </a:p>
+        </p:txBody>
+      </p:sp>
+      <p:sp>
+        <p:nvSpPr>
+          <p:cNvPr id="14" name="TextBox 13"/>
+          <p:cNvSpPr txBox="1"/>
+          <p:nvPr/>
+        </p:nvSpPr>
+        <p:spPr>
+          <a:xfrm>
+            <a:off x="731520" y="1981200"/>
+            <a:ext cx="1554480" cy="274320"/>
+          </a:xfrm>
+          <a:prstGeom prst="rect">
+            <a:avLst/>
+          </a:prstGeom>
+          <a:noFill/>
+        </p:spPr>
+        <p:txBody>
+          <a:bodyPr wrap="square">
+            <a:spAutoFit/>
+          </a:bodyPr>
+          <a:lstStyle/>
+          <a:p>
+            <a:r>
+              <a:rPr sz="900" b="1">
+                <a:solidFill>
+                  <a:srgbClr val="13135E"/>
+                </a:solidFill>
+                <a:latin typeface="Arial"/>
+              </a:rPr>
+              <a:t>Git</a:t>
+            </a:r>
+          </a:p>
+        </p:txBody>
+      </p:sp>
+      <p:sp>
+        <p:nvSpPr>
+          <p:cNvPr id="15" name="TextBox 14"/>
+          <p:cNvSpPr txBox="1"/>
+          <p:nvPr/>
+        </p:nvSpPr>
+        <p:spPr>
+          <a:xfrm>
+            <a:off x="2377440" y="1981200"/>
+            <a:ext cx="3016000" cy="274320"/>
+          </a:xfrm>
+          <a:prstGeom prst="rect">
+            <a:avLst/>
+          </a:prstGeom>
+          <a:noFill/>
+        </p:spPr>
+        <p:txBody>
+          <a:bodyPr wrap="square">
+            <a:spAutoFit/>
+          </a:bodyPr>
+          <a:lstStyle/>
+          <a:p>
+            <a:r>
+              <a:rPr sz="900" b="0">
+                <a:solidFill>
+                  <a:srgbClr val="434343"/>
+                </a:solidFill>
+                <a:latin typeface="Consolas"/>
+              </a:rPr>
+              <a:t>xcode-select --install</a:t>
+            </a:r>
+            <a:r>
+              <a:rPr sz="900" b="0">
+                <a:solidFill>
+                  <a:srgbClr val="999999"/>
+                </a:solidFill>
+                <a:latin typeface="Arial"/>
+              </a:rPr>
+              <a:t>  · or brew install git</a:t>
+            </a:r>
+          </a:p>
+        </p:txBody>
+      </p:sp>
+      <p:sp>
+        <p:nvSpPr>
+          <p:cNvPr id="16" name="TextBox 15"/>
+          <p:cNvSpPr txBox="1"/>
+          <p:nvPr/>
+        </p:nvSpPr>
+        <p:spPr>
+          <a:xfrm>
+            <a:off x="5486400" y="1981200"/>
+            <a:ext cx="3016000" cy="274320"/>
+          </a:xfrm>
+          <a:prstGeom prst="rect">
+            <a:avLst/>
+          </a:prstGeom>
+          <a:noFill/>
+        </p:spPr>
+        <p:txBody>
+          <a:bodyPr wrap="square">
+            <a:spAutoFit/>
+          </a:bodyPr>
+          <a:lstStyle/>
+          <a:p>
+            <a:r>
+              <a:rPr sz="900" b="0">
+                <a:solidFill>
+                  <a:srgbClr val="434343"/>
+                </a:solidFill>
+                <a:latin typeface="Consolas"/>
+              </a:rPr>
+              <a:t>winget install Git.Git</a:t>
+            </a:r>
+          </a:p>
+        </p:txBody>
+      </p:sp>
+      <p:sp>
+        <p:nvSpPr>
+          <p:cNvPr id="17" name="Rounded Rectangle 16"/>
+          <p:cNvSpPr/>
+          <p:nvPr/>
+        </p:nvSpPr>
+        <p:spPr>
+          <a:xfrm>
+            <a:off x="548640" y="2331720"/>
+            <a:ext cx="8046720" cy="393192"/>
+          </a:xfrm>
+          <a:prstGeom prst="roundRect">
+            <a:avLst/>
+          </a:prstGeom>
+          <a:solidFill>
+            <a:srgbClr val="FFFFFF"/>
+          </a:solidFill>
+          <a:ln w="15875">
+            <a:solidFill>
+              <a:srgbClr val="CCD9FF"/>
+            </a:solidFill>
+          </a:ln>
+          <a:effectLst/>
+        </p:spPr>
+        <p:style>
+          <a:lnRef idx="1">
+            <a:schemeClr val="accent1"/>
+          </a:lnRef>
+          <a:fillRef idx="3">
+            <a:schemeClr val="accent1"/>
+          </a:fillRef>
+          <a:effectRef idx="2">
+            <a:schemeClr val="accent1"/>
+          </a:effectRef>
+          <a:fontRef idx="minor">
+            <a:schemeClr val="lt1"/>
+          </a:fontRef>
+        </p:style>
+        <p:txBody>
+          <a:bodyPr rtlCol="0" anchor="ctr"/>
+          <a:lstStyle/>
+          <a:p>
+            <a:pPr algn="ctr"/>
+          </a:p>
+        </p:txBody>
+      </p:sp>
+      <p:sp>
+        <p:nvSpPr>
+          <p:cNvPr id="18" name="TextBox 17"/>
+          <p:cNvSpPr txBox="1"/>
+          <p:nvPr/>
+        </p:nvSpPr>
+        <p:spPr>
+          <a:xfrm>
+            <a:off x="731520" y="2392680"/>
+            <a:ext cx="1554480" cy="274320"/>
+          </a:xfrm>
+          <a:prstGeom prst="rect">
+            <a:avLst/>
+          </a:prstGeom>
+          <a:noFill/>
+        </p:spPr>
+        <p:txBody>
+          <a:bodyPr wrap="square">
+            <a:spAutoFit/>
+          </a:bodyPr>
+          <a:lstStyle/>
+          <a:p>
+            <a:r>
+              <a:rPr sz="900" b="1">
+                <a:solidFill>
+                  <a:srgbClr val="13135E"/>
+                </a:solidFill>
+                <a:latin typeface="Arial"/>
+              </a:rPr>
+              <a:t>nvm (Node manager)</a:t>
+            </a:r>
+          </a:p>
+        </p:txBody>
+      </p:sp>
+      <p:sp>
+        <p:nvSpPr>
+          <p:cNvPr id="19" name="TextBox 18"/>
+          <p:cNvSpPr txBox="1"/>
+          <p:nvPr/>
+        </p:nvSpPr>
+        <p:spPr>
+          <a:xfrm>
+            <a:off x="2377440" y="2392680"/>
+            <a:ext cx="3016000" cy="274320"/>
+          </a:xfrm>
+          <a:prstGeom prst="rect">
+            <a:avLst/>
+          </a:prstGeom>
+          <a:noFill/>
+        </p:spPr>
+        <p:txBody>
+          <a:bodyPr wrap="square">
+            <a:spAutoFit/>
+          </a:bodyPr>
+          <a:lstStyle/>
+          <a:p>
+            <a:r>
+              <a:rPr sz="900" b="0">
+                <a:solidFill>
+                  <a:srgbClr val="434343"/>
+                </a:solidFill>
+                <a:latin typeface="Consolas"/>
+              </a:rPr>
+              <a:t>brew install nvm</a:t>
+            </a:r>
+          </a:p>
+        </p:txBody>
+      </p:sp>
+      <p:sp>
+        <p:nvSpPr>
+          <p:cNvPr id="20" name="TextBox 19"/>
+          <p:cNvSpPr txBox="1"/>
+          <p:nvPr/>
+        </p:nvSpPr>
+        <p:spPr>
+          <a:xfrm>
+            <a:off x="5486400" y="2392680"/>
+            <a:ext cx="3016000" cy="274320"/>
+          </a:xfrm>
+          <a:prstGeom prst="rect">
+            <a:avLst/>
+          </a:prstGeom>
+          <a:noFill/>
+        </p:spPr>
+        <p:txBody>
+          <a:bodyPr wrap="square">
+            <a:spAutoFit/>
+          </a:bodyPr>
+          <a:lstStyle/>
+          <a:p>
+            <a:r>
+              <a:rPr sz="900" b="0">
+                <a:solidFill>
+                  <a:srgbClr val="434343"/>
+                </a:solidFill>
+                <a:latin typeface="Consolas"/>
+              </a:rPr>
+              <a:t>winget install CoreyButler.NVMforWindows</a:t>
+            </a:r>
+          </a:p>
+        </p:txBody>
+      </p:sp>
+      <p:sp>
+        <p:nvSpPr>
+          <p:cNvPr id="21" name="Rounded Rectangle 20"/>
+          <p:cNvSpPr/>
+          <p:nvPr/>
+        </p:nvSpPr>
+        <p:spPr>
+          <a:xfrm>
+            <a:off x="548640" y="2743200"/>
+            <a:ext cx="8046720" cy="393192"/>
+          </a:xfrm>
+          <a:prstGeom prst="roundRect">
+            <a:avLst/>
+          </a:prstGeom>
+          <a:solidFill>
+            <a:srgbClr val="E2ECFF"/>
+          </a:solidFill>
+          <a:ln>
+            <a:noFill/>
+          </a:ln>
+          <a:effectLst/>
+        </p:spPr>
+        <p:style>
+          <a:lnRef idx="1">
+            <a:schemeClr val="accent1"/>
+          </a:lnRef>
+          <a:fillRef idx="3">
+            <a:schemeClr val="accent1"/>
+          </a:fillRef>
+          <a:effectRef idx="2">
+            <a:schemeClr val="accent1"/>
+          </a:effectRef>
+          <a:fontRef idx="minor">
+            <a:schemeClr val="lt1"/>
+          </a:fontRef>
+        </p:style>
+        <p:txBody>
+          <a:bodyPr rtlCol="0" anchor="ctr"/>
+          <a:lstStyle/>
+          <a:p>
+            <a:pPr algn="ctr"/>
+          </a:p>
+        </p:txBody>
+      </p:sp>
+      <p:sp>
+        <p:nvSpPr>
+          <p:cNvPr id="22" name="TextBox 21"/>
+          <p:cNvSpPr txBox="1"/>
+          <p:nvPr/>
+        </p:nvSpPr>
+        <p:spPr>
+          <a:xfrm>
+            <a:off x="731520" y="2804160"/>
+            <a:ext cx="1554480" cy="274320"/>
+          </a:xfrm>
+          <a:prstGeom prst="rect">
+            <a:avLst/>
+          </a:prstGeom>
+          <a:noFill/>
+        </p:spPr>
+        <p:txBody>
+          <a:bodyPr wrap="square">
+            <a:spAutoFit/>
+          </a:bodyPr>
+          <a:lstStyle/>
+          <a:p>
+            <a:r>
+              <a:rPr sz="900" b="1">
+                <a:solidFill>
+                  <a:srgbClr val="13135E"/>
+                </a:solidFill>
+                <a:latin typeface="Arial"/>
+              </a:rPr>
+              <a:t>Node LTS ≥ 20.19 + npm</a:t>
+            </a:r>
+          </a:p>
+        </p:txBody>
+      </p:sp>
+      <p:sp>
+        <p:nvSpPr>
+          <p:cNvPr id="23" name="TextBox 22"/>
+          <p:cNvSpPr txBox="1"/>
+          <p:nvPr/>
+        </p:nvSpPr>
+        <p:spPr>
+          <a:xfrm>
+            <a:off x="2377440" y="2804160"/>
+            <a:ext cx="3016000" cy="274320"/>
+          </a:xfrm>
+          <a:prstGeom prst="rect">
+            <a:avLst/>
+          </a:prstGeom>
+          <a:noFill/>
+        </p:spPr>
+        <p:txBody>
+          <a:bodyPr wrap="square">
+            <a:spAutoFit/>
+          </a:bodyPr>
+          <a:lstStyle/>
+          <a:p>
+            <a:r>
+              <a:rPr sz="900" b="0">
+                <a:solidFill>
+                  <a:srgbClr val="434343"/>
+                </a:solidFill>
+                <a:latin typeface="Consolas"/>
+              </a:rPr>
+              <a:t>nvm install 20 &amp;&amp; nvm use</a:t>
+            </a:r>
+          </a:p>
+        </p:txBody>
+      </p:sp>
+      <p:sp>
+        <p:nvSpPr>
+          <p:cNvPr id="24" name="TextBox 23"/>
+          <p:cNvSpPr txBox="1"/>
+          <p:nvPr/>
+        </p:nvSpPr>
+        <p:spPr>
+          <a:xfrm>
+            <a:off x="5486400" y="2804160"/>
+            <a:ext cx="3016000" cy="274320"/>
+          </a:xfrm>
+          <a:prstGeom prst="rect">
+            <a:avLst/>
+          </a:prstGeom>
+          <a:noFill/>
+        </p:spPr>
+        <p:txBody>
+          <a:bodyPr wrap="square">
+            <a:spAutoFit/>
+          </a:bodyPr>
+          <a:lstStyle/>
+          <a:p>
+            <a:r>
+              <a:rPr sz="900" b="0">
+                <a:solidFill>
+                  <a:srgbClr val="434343"/>
+                </a:solidFill>
+                <a:latin typeface="Consolas"/>
+              </a:rPr>
+              <a:t>nvm install 20 &amp;&amp; nvm use 20</a:t>
+            </a:r>
+          </a:p>
+        </p:txBody>
+      </p:sp>
+      <p:sp>
+        <p:nvSpPr>
+          <p:cNvPr id="25" name="Rounded Rectangle 24"/>
+          <p:cNvSpPr/>
+          <p:nvPr/>
+        </p:nvSpPr>
+        <p:spPr>
+          <a:xfrm>
+            <a:off x="548640" y="3154680"/>
+            <a:ext cx="8046720" cy="393192"/>
+          </a:xfrm>
+          <a:prstGeom prst="roundRect">
+            <a:avLst/>
+          </a:prstGeom>
+          <a:solidFill>
+            <a:srgbClr val="FFFFFF"/>
+          </a:solidFill>
+          <a:ln w="15875">
+            <a:solidFill>
+              <a:srgbClr val="CCD9FF"/>
+            </a:solidFill>
+          </a:ln>
+          <a:effectLst/>
+        </p:spPr>
+        <p:style>
+          <a:lnRef idx="1">
+            <a:schemeClr val="accent1"/>
+          </a:lnRef>
+          <a:fillRef idx="3">
+            <a:schemeClr val="accent1"/>
+          </a:fillRef>
+          <a:effectRef idx="2">
+            <a:schemeClr val="accent1"/>
+          </a:effectRef>
+          <a:fontRef idx="minor">
+            <a:schemeClr val="lt1"/>
+          </a:fontRef>
+        </p:style>
+        <p:txBody>
+          <a:bodyPr rtlCol="0" anchor="ctr"/>
+          <a:lstStyle/>
+          <a:p>
+            <a:pPr algn="ctr"/>
+          </a:p>
+        </p:txBody>
+      </p:sp>
+      <p:sp>
+        <p:nvSpPr>
+          <p:cNvPr id="26" name="TextBox 25"/>
+          <p:cNvSpPr txBox="1"/>
+          <p:nvPr/>
+        </p:nvSpPr>
+        <p:spPr>
+          <a:xfrm>
+            <a:off x="731520" y="3215640"/>
+            <a:ext cx="1554480" cy="274320"/>
+          </a:xfrm>
+          <a:prstGeom prst="rect">
+            <a:avLst/>
+          </a:prstGeom>
+          <a:noFill/>
+        </p:spPr>
+        <p:txBody>
+          <a:bodyPr wrap="square">
+            <a:spAutoFit/>
+          </a:bodyPr>
+          <a:lstStyle/>
+          <a:p>
+            <a:r>
+              <a:rPr sz="900" b="1">
+                <a:solidFill>
+                  <a:srgbClr val="13135E"/>
+                </a:solidFill>
+                <a:latin typeface="Arial"/>
+              </a:rPr>
+              <a:t>GitHub CLI</a:t>
+            </a:r>
+          </a:p>
+        </p:txBody>
+      </p:sp>
+      <p:sp>
+        <p:nvSpPr>
+          <p:cNvPr id="27" name="TextBox 26"/>
+          <p:cNvSpPr txBox="1"/>
+          <p:nvPr/>
+        </p:nvSpPr>
+        <p:spPr>
+          <a:xfrm>
+            <a:off x="2377440" y="3215640"/>
+            <a:ext cx="3016000" cy="274320"/>
+          </a:xfrm>
+          <a:prstGeom prst="rect">
+            <a:avLst/>
+          </a:prstGeom>
+          <a:noFill/>
+        </p:spPr>
+        <p:txBody>
+          <a:bodyPr wrap="square">
+            <a:spAutoFit/>
+          </a:bodyPr>
+          <a:lstStyle/>
+          <a:p>
+            <a:r>
+              <a:rPr sz="900" b="0">
+                <a:solidFill>
+                  <a:srgbClr val="434343"/>
+                </a:solidFill>
+                <a:latin typeface="Consolas"/>
+              </a:rPr>
+              <a:t>brew install gh</a:t>
+            </a:r>
+            <a:r>
+              <a:rPr sz="900" b="0">
+                <a:solidFill>
+                  <a:srgbClr val="999999"/>
+                </a:solidFill>
+                <a:latin typeface="Arial"/>
+              </a:rPr>
+              <a:t>  → gh auth login</a:t>
+            </a:r>
+          </a:p>
+        </p:txBody>
+      </p:sp>
+      <p:sp>
+        <p:nvSpPr>
+          <p:cNvPr id="28" name="TextBox 27"/>
+          <p:cNvSpPr txBox="1"/>
+          <p:nvPr/>
+        </p:nvSpPr>
+        <p:spPr>
+          <a:xfrm>
+            <a:off x="5486400" y="3215640"/>
+            <a:ext cx="3016000" cy="274320"/>
+          </a:xfrm>
+          <a:prstGeom prst="rect">
+            <a:avLst/>
+          </a:prstGeom>
+          <a:noFill/>
+        </p:spPr>
+        <p:txBody>
+          <a:bodyPr wrap="square">
+            <a:spAutoFit/>
+          </a:bodyPr>
+          <a:lstStyle/>
+          <a:p>
+            <a:r>
+              <a:rPr sz="900" b="0">
+                <a:solidFill>
+                  <a:srgbClr val="434343"/>
+                </a:solidFill>
+                <a:latin typeface="Consolas"/>
+              </a:rPr>
+              <a:t>winget install GitHub.cli</a:t>
+            </a:r>
+            <a:r>
+              <a:rPr sz="900" b="0">
+                <a:solidFill>
+                  <a:srgbClr val="999999"/>
+                </a:solidFill>
+                <a:latin typeface="Arial"/>
+              </a:rPr>
+              <a:t>  → gh auth login</a:t>
+            </a:r>
+          </a:p>
+        </p:txBody>
+      </p:sp>
+      <p:sp>
+        <p:nvSpPr>
+          <p:cNvPr id="29" name="Rounded Rectangle 28"/>
+          <p:cNvSpPr/>
+          <p:nvPr/>
+        </p:nvSpPr>
+        <p:spPr>
+          <a:xfrm>
+            <a:off x="548640" y="3566160"/>
+            <a:ext cx="8046720" cy="393192"/>
+          </a:xfrm>
+          <a:prstGeom prst="roundRect">
+            <a:avLst/>
+          </a:prstGeom>
+          <a:solidFill>
+            <a:srgbClr val="E2ECFF"/>
+          </a:solidFill>
+          <a:ln>
+            <a:noFill/>
+          </a:ln>
+          <a:effectLst/>
+        </p:spPr>
+        <p:style>
+          <a:lnRef idx="1">
+            <a:schemeClr val="accent1"/>
+          </a:lnRef>
+          <a:fillRef idx="3">
+            <a:schemeClr val="accent1"/>
+          </a:fillRef>
+          <a:effectRef idx="2">
+            <a:schemeClr val="accent1"/>
+          </a:effectRef>
+          <a:fontRef idx="minor">
+            <a:schemeClr val="lt1"/>
+          </a:fontRef>
+        </p:style>
+        <p:txBody>
+          <a:bodyPr rtlCol="0" anchor="ctr"/>
+          <a:lstStyle/>
+          <a:p>
+            <a:pPr algn="ctr"/>
+          </a:p>
+        </p:txBody>
+      </p:sp>
+      <p:sp>
+        <p:nvSpPr>
+          <p:cNvPr id="30" name="TextBox 29"/>
+          <p:cNvSpPr txBox="1"/>
+          <p:nvPr/>
+        </p:nvSpPr>
+        <p:spPr>
+          <a:xfrm>
+            <a:off x="731520" y="3627120"/>
+            <a:ext cx="1554480" cy="274320"/>
+          </a:xfrm>
+          <a:prstGeom prst="rect">
+            <a:avLst/>
+          </a:prstGeom>
+          <a:noFill/>
+        </p:spPr>
+        <p:txBody>
+          <a:bodyPr wrap="square">
+            <a:spAutoFit/>
+          </a:bodyPr>
+          <a:lstStyle/>
+          <a:p>
+            <a:r>
+              <a:rPr sz="900" b="1">
+                <a:solidFill>
+                  <a:srgbClr val="13135E"/>
+                </a:solidFill>
+                <a:latin typeface="Arial"/>
+              </a:rPr>
+              <a:t>Claude Code</a:t>
+            </a:r>
+          </a:p>
+        </p:txBody>
+      </p:sp>
+      <p:sp>
+        <p:nvSpPr>
+          <p:cNvPr id="31" name="TextBox 30"/>
+          <p:cNvSpPr txBox="1"/>
+          <p:nvPr/>
+        </p:nvSpPr>
+        <p:spPr>
+          <a:xfrm>
+            <a:off x="2377440" y="3627120"/>
+            <a:ext cx="3016000" cy="274320"/>
+          </a:xfrm>
+          <a:prstGeom prst="rect">
+            <a:avLst/>
+          </a:prstGeom>
+          <a:noFill/>
+        </p:spPr>
+        <p:txBody>
+          <a:bodyPr wrap="square">
+            <a:spAutoFit/>
+          </a:bodyPr>
+          <a:lstStyle/>
+          <a:p>
+            <a:r>
+              <a:rPr sz="900" b="0">
+                <a:solidFill>
+                  <a:srgbClr val="434343"/>
+                </a:solidFill>
+                <a:latin typeface="Consolas"/>
+              </a:rPr>
+              <a:t>curl -fsSL https://claude.ai/install.sh | bash</a:t>
+            </a:r>
+          </a:p>
+        </p:txBody>
+      </p:sp>
+      <p:sp>
+        <p:nvSpPr>
+          <p:cNvPr id="32" name="TextBox 31"/>
+          <p:cNvSpPr txBox="1"/>
+          <p:nvPr/>
+        </p:nvSpPr>
+        <p:spPr>
+          <a:xfrm>
+            <a:off x="5486400" y="3627120"/>
+            <a:ext cx="3016000" cy="274320"/>
+          </a:xfrm>
+          <a:prstGeom prst="rect">
+            <a:avLst/>
+          </a:prstGeom>
+          <a:noFill/>
+        </p:spPr>
+        <p:txBody>
+          <a:bodyPr wrap="square">
+            <a:spAutoFit/>
+          </a:bodyPr>
+          <a:lstStyle/>
+          <a:p>
+            <a:r>
+              <a:rPr sz="900" b="0">
+                <a:solidFill>
+                  <a:srgbClr val="434343"/>
+                </a:solidFill>
+                <a:latin typeface="Consolas"/>
+              </a:rPr>
+              <a:t>irm https://claude.ai/install.ps1 | iex</a:t>
+            </a:r>
+          </a:p>
+        </p:txBody>
+      </p:sp>
+      <p:sp>
+        <p:nvSpPr>
+          <p:cNvPr id="33" name="Rounded Rectangle 32"/>
+          <p:cNvSpPr/>
+          <p:nvPr/>
+        </p:nvSpPr>
+        <p:spPr>
+          <a:xfrm>
+            <a:off x="548640" y="3977640"/>
+            <a:ext cx="8046720" cy="393192"/>
+          </a:xfrm>
+          <a:prstGeom prst="roundRect">
+            <a:avLst/>
+          </a:prstGeom>
+          <a:solidFill>
+            <a:srgbClr val="FFFFFF"/>
+          </a:solidFill>
+          <a:ln w="15875">
+            <a:solidFill>
+              <a:srgbClr val="CCD9FF"/>
+            </a:solidFill>
+          </a:ln>
+          <a:effectLst/>
+        </p:spPr>
+        <p:style>
+          <a:lnRef idx="1">
+            <a:schemeClr val="accent1"/>
+          </a:lnRef>
+          <a:fillRef idx="3">
+            <a:schemeClr val="accent1"/>
+          </a:fillRef>
+          <a:effectRef idx="2">
+            <a:schemeClr val="accent1"/>
+          </a:effectRef>
+          <a:fontRef idx="minor">
+            <a:schemeClr val="lt1"/>
+          </a:fontRef>
+        </p:style>
+        <p:txBody>
+          <a:bodyPr rtlCol="0" anchor="ctr"/>
+          <a:lstStyle/>
+          <a:p>
+            <a:pPr algn="ctr"/>
+          </a:p>
+        </p:txBody>
+      </p:sp>
+      <p:sp>
+        <p:nvSpPr>
+          <p:cNvPr id="34" name="TextBox 33"/>
+          <p:cNvSpPr txBox="1"/>
+          <p:nvPr/>
+        </p:nvSpPr>
+        <p:spPr>
+          <a:xfrm>
+            <a:off x="731520" y="4038600"/>
+            <a:ext cx="1554480" cy="274320"/>
+          </a:xfrm>
+          <a:prstGeom prst="rect">
+            <a:avLst/>
+          </a:prstGeom>
+          <a:noFill/>
+        </p:spPr>
+        <p:txBody>
+          <a:bodyPr wrap="square">
+            <a:spAutoFit/>
+          </a:bodyPr>
+          <a:lstStyle/>
+          <a:p>
+            <a:r>
+              <a:rPr sz="900" b="1">
+                <a:solidFill>
+                  <a:srgbClr val="13135E"/>
+                </a:solidFill>
+                <a:latin typeface="Arial"/>
+              </a:rPr>
+              <a:t>VS Code (or your editor)</a:t>
+            </a:r>
+          </a:p>
+        </p:txBody>
+      </p:sp>
+      <p:sp>
+        <p:nvSpPr>
+          <p:cNvPr id="35" name="TextBox 34"/>
+          <p:cNvSpPr txBox="1"/>
+          <p:nvPr/>
+        </p:nvSpPr>
+        <p:spPr>
+          <a:xfrm>
+            <a:off x="2377440" y="4038600"/>
+            <a:ext cx="3016000" cy="274320"/>
+          </a:xfrm>
+          <a:prstGeom prst="rect">
+            <a:avLst/>
+          </a:prstGeom>
+          <a:noFill/>
+        </p:spPr>
+        <p:txBody>
+          <a:bodyPr wrap="square">
+            <a:spAutoFit/>
+          </a:bodyPr>
+          <a:lstStyle/>
+          <a:p>
+            <a:r>
+              <a:rPr sz="900" b="0">
+                <a:solidFill>
+                  <a:srgbClr val="434343"/>
+                </a:solidFill>
+                <a:latin typeface="Consolas"/>
+              </a:rPr>
+              <a:t>brew install --cask visual-studio-code</a:t>
+            </a:r>
+          </a:p>
+        </p:txBody>
+      </p:sp>
+      <p:sp>
+        <p:nvSpPr>
+          <p:cNvPr id="36" name="TextBox 35"/>
+          <p:cNvSpPr txBox="1"/>
+          <p:nvPr/>
+        </p:nvSpPr>
+        <p:spPr>
+          <a:xfrm>
+            <a:off x="5486400" y="4038600"/>
+            <a:ext cx="3016000" cy="274320"/>
+          </a:xfrm>
+          <a:prstGeom prst="rect">
+            <a:avLst/>
+          </a:prstGeom>
+          <a:noFill/>
+        </p:spPr>
+        <p:txBody>
+          <a:bodyPr wrap="square">
+            <a:spAutoFit/>
+          </a:bodyPr>
+          <a:lstStyle/>
+          <a:p>
+            <a:r>
+              <a:rPr sz="900" b="0">
+                <a:solidFill>
+                  <a:srgbClr val="434343"/>
+                </a:solidFill>
+                <a:latin typeface="Consolas"/>
+              </a:rPr>
+              <a:t>winget install Microsoft.VisualStudioCode</a:t>
+            </a:r>
+          </a:p>
+        </p:txBody>
+      </p:sp>
+      <p:sp>
+        <p:nvSpPr>
+          <p:cNvPr id="37" name="Rounded Rectangle 36"/>
+          <p:cNvSpPr/>
+          <p:nvPr/>
+        </p:nvSpPr>
+        <p:spPr>
+          <a:xfrm>
+            <a:off x="548640" y="4404360"/>
+            <a:ext cx="8046720" cy="396240"/>
+          </a:xfrm>
+          <a:prstGeom prst="roundRect">
+            <a:avLst/>
+          </a:prstGeom>
+          <a:solidFill>
+            <a:srgbClr val="E2ECFF"/>
+          </a:solidFill>
+          <a:ln>
+            <a:noFill/>
+          </a:ln>
+          <a:effectLst/>
+        </p:spPr>
+        <p:style>
+          <a:lnRef idx="1">
+            <a:schemeClr val="accent1"/>
+          </a:lnRef>
+          <a:fillRef idx="3">
+            <a:schemeClr val="accent1"/>
+          </a:fillRef>
+          <a:effectRef idx="2">
+            <a:schemeClr val="accent1"/>
+          </a:effectRef>
+          <a:fontRef idx="minor">
+            <a:schemeClr val="lt1"/>
+          </a:fontRef>
+        </p:style>
+        <p:txBody>
+          <a:bodyPr rtlCol="0" anchor="ctr"/>
+          <a:lstStyle/>
+          <a:p>
+            <a:pPr algn="ctr"/>
+          </a:p>
+        </p:txBody>
+      </p:sp>
+      <p:sp>
+        <p:nvSpPr>
+          <p:cNvPr id="38" name="Rectangle 37"/>
+          <p:cNvSpPr/>
+          <p:nvPr/>
+        </p:nvSpPr>
+        <p:spPr>
+          <a:xfrm>
+            <a:off x="548640" y="4404360"/>
+            <a:ext cx="64008" cy="396240"/>
+          </a:xfrm>
+          <a:prstGeom prst="rect">
+            <a:avLst/>
+          </a:prstGeom>
+          <a:solidFill>
+            <a:srgbClr val="403FE8"/>
+          </a:solidFill>
+          <a:ln>
+            <a:noFill/>
+          </a:ln>
+          <a:effectLst/>
+        </p:spPr>
+        <p:style>
+          <a:lnRef idx="1">
+            <a:schemeClr val="accent1"/>
+          </a:lnRef>
+          <a:fillRef idx="3">
+            <a:schemeClr val="accent1"/>
+          </a:fillRef>
+          <a:effectRef idx="2">
+            <a:schemeClr val="accent1"/>
+          </a:effectRef>
+          <a:fontRef idx="minor">
+            <a:schemeClr val="lt1"/>
+          </a:fontRef>
+        </p:style>
+        <p:txBody>
+          <a:bodyPr rtlCol="0" anchor="ctr"/>
+          <a:lstStyle/>
+          <a:p>
+            <a:pPr algn="ctr"/>
+          </a:p>
+        </p:txBody>
+      </p:sp>
+      <p:sp>
+        <p:nvSpPr>
+          <p:cNvPr id="39" name="TextBox 38"/>
+          <p:cNvSpPr txBox="1"/>
+          <p:nvPr/>
+        </p:nvSpPr>
+        <p:spPr>
+          <a:xfrm>
+            <a:off x="731520" y="4442460"/>
+            <a:ext cx="7772400" cy="320040"/>
+          </a:xfrm>
+          <a:prstGeom prst="rect">
+            <a:avLst/>
+          </a:prstGeom>
+          <a:noFill/>
+        </p:spPr>
+        <p:txBody>
+          <a:bodyPr wrap="square">
+            <a:spAutoFit/>
+          </a:bodyPr>
+          <a:lstStyle/>
+          <a:p>
+            <a:r>
+              <a:rPr sz="850" b="1">
+                <a:solidFill>
+                  <a:srgbClr val="403FE8"/>
+                </a:solidFill>
+                <a:latin typeface="Arial"/>
+              </a:rPr>
+              <a:t>ACCOUNTS   </a:t>
+            </a:r>
+            <a:r>
+              <a:rPr sz="850" b="0">
+                <a:solidFill>
+                  <a:srgbClr val="434343"/>
+                </a:solidFill>
+                <a:latin typeface="Arial"/>
+              </a:rPr>
+              <a:t>GitHub account + Claude Code seat (EDS-provisioned) — confirm both logins before lab day.</a:t>
+            </a:r>
+          </a:p>
+          <a:p>
+            <a:r>
+              <a:rPr sz="850" b="1">
+                <a:solidFill>
+                  <a:srgbClr val="403FE8"/>
+                </a:solidFill>
+                <a:latin typeface="Arial"/>
+              </a:rPr>
+              <a:t>VERIFY   </a:t>
+            </a:r>
+            <a:r>
+              <a:rPr sz="850" b="0">
+                <a:solidFill>
+                  <a:srgbClr val="434343"/>
+                </a:solidFill>
+                <a:latin typeface="Consolas"/>
+              </a:rPr>
+              <a:t>git --version · node --version (≥ 20.19) · gh auth status · claude --version</a:t>
+            </a:r>
+          </a:p>
+        </p:txBody>
+      </p:sp>
+    </p:spTree>
+  </p:cSld>
+  <p:clrMapOvr>
+    <a:masterClrMapping/>
+  </p:clrMapOvr>
+</p:sld>
+</file>
+
 <file path=ppt/slides/slide3.xml><?xml version="1.0" encoding="utf-8"?>
 <p:sld xmlns:a="http://schemas.openxmlformats.org/drawingml/2006/main" xmlns:p="http://schemas.openxmlformats.org/presentationml/2006/main" xmlns:r="http://schemas.openxmlformats.org/officeDocument/2006/relationships">
   <p:cSld>
@@ -17204,7 +18747,7 @@
                 </a:solidFill>
                 <a:latin typeface="Arial"/>
               </a:rPr>
-              <a:t>Clone it, then from the repo root seed the backlog:  ./scripts/setup-repo.sh  (Windows: .\scripts\setup-repo.ps1). Creates the lab labels + issues — needs gh auth login.</a:t>
+              <a:t>Clone it, then from the repo root seed the backlog:  ./scripts/setup-repo.sh  (Windows: .\scripts\setup-repo.ps1). Creates the lab labels + issues — gh login done on the previous slide.</a:t>
             </a:r>
           </a:p>
           <a:p>
@@ -17232,7 +18775,7 @@
                 </a:solidFill>
                 <a:latin typeface="Arial"/>
               </a:rPr>
-              <a:t>Install &amp; run:  npm install · npm run reset-db · npm run dev  (client :5173, API :3001). Node 20+.</a:t>
+              <a:t>Install &amp; run:  npm install · npm run reset-db · npm run dev  (client :5173, API :3001). Node LTS ≥ 20.19 — nvm use reads .nvmrc.</a:t>
             </a:r>
           </a:p>
           <a:p>

</xml_diff>

<commit_message>
docs: remove client identifiers from Lab 1.b instructor assets
This repo is public and is the canonical source students pull handouts
from, so it should not name the client.

Two references, each present in three artifacts (notes, deck, PDF):
- "EDS-provisioned Claude Code seat" -> "company-provisioned"
- "#extra-duty-solutions-ai-training" -> "your team's AI-training
  Slack channel"; the presenter notes now tell the instructor to say
  the real channel name aloud from the cohort setup sheet

Note both also appeared on visible slides (24, 25), not only in the
speaker notes. The deck XML was patched in place and the PDF
regenerated from it — same LibreOffice version that produced the
original, 25 pages before and after, no layout drift.

Co-Authored-By: Claude Opus 5 (1M context) <noreply@anthropic.com>
</commit_message>
<xml_diff>
--- a/docs/instructor/lab-1b-bugfix-test-driven.pptx
+++ b/docs/instructor/lab-1b-bugfix-test-driven.pptx
@@ -1646,7 +1646,7 @@
           <a:lstStyle/>
           <a:p>
             <a:r>
-              <a:t>Land the takeaway (~5 min): the LOOP is the transferable skill, not any one bug. Walk the ship checklist. Point everyone to the #extra-duty-solutions-ai-training Slack channel to ask questions and share their PRs.</a:t>
+              <a:t>Land the takeaway (~5 min): the LOOP is the transferable skill, not any one bug. Walk the ship checklist. Point everyone to the team's AI-training Slack channel to ask questions and share their PRs.</a:t>
             </a:r>
           </a:p>
         </p:txBody>
@@ -1716,7 +1716,7 @@
           <a:lstStyle/>
           <a:p>
             <a:r>
-              <a:t>One-time install, ideally before lab day (~10 min). macOS column assumes Homebrew, Windows assumes winget (built into Win 10/11) — fallback for both is each tool’s download page. Why each tool: git drives the branch/PR flow; nvm makes `nvm use` match the repo’s .nvmrc; Node floor is LTS 20.19+ because Vite 7 requires it — 20, 22, or 24 LTS all work, odd majors (23) print engine warnings that confuse people; GitHub CLI powers the issue-seeding script and PR flow (`gh auth login` is the step people forget); Claude Code uses the native installer — self-updating and avoids npm -g permission problems on locked-down machines; any editor is fine, the demo narrates from VS Code. Accounts: a GitHub account plus an EDS-provisioned Claude Code seat — have everyone run the VERIFY line and complete a Claude login BEFORE lab day; pair anyone broken at the door rather than during the demo.</a:t>
+              <a:t>One-time install, ideally before lab day (~10 min). macOS column assumes Homebrew, Windows assumes winget (built into Win 10/11) — fallback for both is each tool’s download page. Why each tool: git drives the branch/PR flow; nvm makes `nvm use` match the repo’s .nvmrc; Node floor is LTS 20.19+ because Vite 7 requires it — 20, 22, or 24 LTS all work, odd majors (23) print engine warnings that confuse people; GitHub CLI powers the issue-seeding script and PR flow (`gh auth login` is the step people forget); Claude Code uses the native installer — self-updating and avoids npm -g permission problems on locked-down machines; any editor is fine, the demo narrates from VS Code. Accounts: a GitHub account plus a company-provisioned Claude Code seat — have everyone run the VERIFY line and complete a Claude login BEFORE lab day; pair anyone broken at the door rather than during the demo.</a:t>
             </a:r>
           </a:p>
         </p:txBody>
@@ -16903,7 +16903,7 @@
                 </a:solidFill>
                 <a:latin typeface="Arial"/>
               </a:rPr>
-              <a:t>Questions &amp; support: #extra-duty-solutions-ai-training on Slack — or ask your instructor.</a:t>
+              <a:t>Questions &amp; support: your team's AI-training channel on Slack — or ask your instructor.</a:t>
             </a:r>
           </a:p>
         </p:txBody>
@@ -18355,7 +18355,7 @@
                 </a:solidFill>
                 <a:latin typeface="Arial"/>
               </a:rPr>
-              <a:t>GitHub account + Claude Code seat (EDS-provisioned) — confirm both logins before lab day.</a:t>
+              <a:t>GitHub account + Claude Code seat (company-provisioned) — confirm both logins before lab day.</a:t>
             </a:r>
           </a:p>
           <a:p>

</xml_diff>